<commit_message>
Sunum sablonu ignore, kullanilmayan demo state kaldirildi
</commit_message>
<xml_diff>
--- a/EMANET-sunum.pptx
+++ b/EMANET-sunum.pptx
@@ -5420,7 +5420,7 @@
                 <a:ea typeface="Inter" pitchFamily="34" charset="-122"/>
                 <a:cs typeface="Inter" pitchFamily="34" charset="-120"/>
               </a:rPr>
-              <a:t>19:10 itibarıyla demo hesap:</a:t>
+              <a:t>19:55 itibarıyla demo hesap:</a:t>
             </a:r>
             <a:endParaRPr lang="en-US" sz="1450" dirty="0"/>
           </a:p>
@@ -5462,7 +5462,7 @@
                 <a:ea typeface="Inter Bold" pitchFamily="34" charset="-122"/>
                 <a:cs typeface="Inter Bold" pitchFamily="34" charset="-120"/>
               </a:rPr>
-              <a:t>279</a:t>
+              <a:t>394</a:t>
             </a:r>
             <a:endParaRPr lang="en-US" sz="4900" dirty="0"/>
           </a:p>
@@ -5546,7 +5546,7 @@
                 <a:ea typeface="Inter" pitchFamily="34" charset="-122"/>
                 <a:cs typeface="Inter" pitchFamily="34" charset="-120"/>
               </a:rPr>
-              <a:t>156 fırsat değerlendirildi</a:t>
+              <a:t>210 fırsat değerlendirildi</a:t>
             </a:r>
             <a:endParaRPr lang="en-US" sz="1450" dirty="0"/>
           </a:p>
@@ -5588,7 +5588,7 @@
                 <a:ea typeface="Inter Bold" pitchFamily="34" charset="-122"/>
                 <a:cs typeface="Inter Bold" pitchFamily="34" charset="-120"/>
               </a:rPr>
-              <a:t>136</a:t>
+              <a:t>184</a:t>
             </a:r>
             <a:endParaRPr lang="en-US" sz="4900" dirty="0"/>
           </a:p>
@@ -5689,7 +5689,7 @@
                 <a:ea typeface="Inter Bold" pitchFamily="34" charset="-122"/>
                 <a:cs typeface="Inter Bold" pitchFamily="34" charset="-120"/>
               </a:rPr>
-              <a:t>%87'si</a:t>
+              <a:t>%88'si</a:t>
             </a:r>
             <a:pPr algn="ctr" indent="0" marL="0">
               <a:lnSpc>
@@ -5748,7 +5748,7 @@
                 <a:ea typeface="Inter Bold" pitchFamily="34" charset="-122"/>
                 <a:cs typeface="Inter Bold" pitchFamily="34" charset="-120"/>
               </a:rPr>
-              <a:t>20</a:t>
+              <a:t>26</a:t>
             </a:r>
             <a:endParaRPr lang="en-US" sz="4900" dirty="0"/>
           </a:p>
@@ -5832,7 +5832,7 @@
                 <a:ea typeface="Inter" pitchFamily="34" charset="-122"/>
                 <a:cs typeface="Inter" pitchFamily="34" charset="-120"/>
               </a:rPr>
-              <a:t>20'si de ajan tarafından kapatıldı</a:t>
+              <a:t>hepsi ajan tarafından kapatıldı</a:t>
             </a:r>
             <a:endParaRPr lang="en-US" sz="1450" dirty="0"/>
           </a:p>
@@ -7153,7 +7153,7 @@
                 <a:ea typeface="Inter Bold" pitchFamily="34" charset="-122"/>
                 <a:cs typeface="Inter Bold" pitchFamily="34" charset="-120"/>
               </a:rPr>
-              <a:t>19:10</a:t>
+              <a:t>19:55</a:t>
             </a:r>
             <a:endParaRPr lang="en-US" sz="1750" dirty="0"/>
           </a:p>
@@ -7195,7 +7195,7 @@
                 <a:ea typeface="Inter" pitchFamily="34" charset="-122"/>
                 <a:cs typeface="Inter" pitchFamily="34" charset="-120"/>
               </a:rPr>
-              <a:t>48 karar, 12 emir, 8 kapanış, 13 red</a:t>
+              <a:t>191 karar, 22 emir, 19 kapanış, 67 red</a:t>
             </a:r>
             <a:endParaRPr lang="en-US" sz="1400" dirty="0"/>
           </a:p>
@@ -8376,7 +8376,7 @@
                 <a:ea typeface="Inter Bold" pitchFamily="34" charset="-122"/>
                 <a:cs typeface="Inter Bold" pitchFamily="34" charset="-120"/>
               </a:rPr>
-              <a:t>1</a:t>
+              <a:t>6</a:t>
             </a:r>
             <a:endParaRPr lang="en-US" sz="1800" dirty="0"/>
           </a:p>
@@ -8531,7 +8531,7 @@
                 <a:ea typeface="Inter Bold" pitchFamily="34" charset="-122"/>
                 <a:cs typeface="Inter Bold" pitchFamily="34" charset="-120"/>
               </a:rPr>
-              <a:t>2</a:t>
+              <a:t>7</a:t>
             </a:r>
             <a:endParaRPr lang="en-US" sz="1800" dirty="0"/>
           </a:p>
@@ -8684,7 +8684,7 @@
                 <a:ea typeface="Inter Bold" pitchFamily="34" charset="-122"/>
                 <a:cs typeface="Inter Bold" pitchFamily="34" charset="-120"/>
               </a:rPr>
-              <a:t>3</a:t>
+              <a:t>8</a:t>
             </a:r>
             <a:endParaRPr lang="en-US" sz="1800" dirty="0"/>
           </a:p>
@@ -8837,7 +8837,7 @@
                 <a:ea typeface="Inter Bold" pitchFamily="34" charset="-122"/>
                 <a:cs typeface="Inter Bold" pitchFamily="34" charset="-120"/>
               </a:rPr>
-              <a:t>4</a:t>
+              <a:t>9</a:t>
             </a:r>
             <a:endParaRPr lang="en-US" sz="1800" dirty="0"/>
           </a:p>

</xml_diff>